<commit_message>
Fix stale speaker notes missed in the Phase 6 presentation update
The earlier pass only edited visible slide text; speaker notes on
slides 9, 15, and 20 still said "seventeen mutation rows" and
described EPSPS as a single-position descriptive case. Fixed to match
the now-correct on-slide numbers (19 rows, EPSPS n=2, significant).

Co-Authored-By: Claude Sonnet 5 <noreply@anthropic.com>
</commit_message>
<xml_diff>
--- a/output/presentations/herbicide_resistance_structural_bioinformatics_talk.pptx
+++ b/output/presentations/herbicide_resistance_structural_bioinformatics_talk.pptx
@@ -1053,7 +1053,7 @@
           <a:p>
             <a:r>
               <a:rPr lang="en-US" dirty="0"/>
-              <a:t>Start by being honest about what this result is: it's the EXPECTED baseline, not the headline. In PPO, ALS/AHAS, and ACCase, real resistance positions sit dramatically closer to the active-site core than random residues. Read the bars: grey is the random mean, always around the 50th percentile by construction; the colored bar is what we observed. ALS positions average the 5th percentile, PPO the 8th, ACCase the 13th — all with p-values well under 0.001. EPSPS points the same direction but has only one accepted position, so we call it descriptive, not a family-level test. The pattern is real and it's strong.</a:t>
+              <a:t>Start by being honest about what this result is: it's the EXPECTED baseline, not the headline. In PPO, ALS/AHAS, and ACCase, real resistance positions sit dramatically closer to the active-site core than random residues. Read the bars: grey is the random mean, always around the 50th percentile by construction; the colored bar is what we observed. ALS positions average the 5th percentile, PPO the 8th, ACCase the 13th — all with p-values well under 0.001. EPSPS now has two accepted positions after adding Thr102Ile, and is itself statistically significant, though it's still the smallest pooled family. The pattern is real and it's strong.</a:t>
             </a:r>
             <a:endParaRPr lang="en-US" dirty="0"/>
           </a:p>
@@ -1581,7 +1581,7 @@
           <a:p>
             <a:r>
               <a:rPr lang="en-US" dirty="0"/>
-              <a:t>Being explicit about limits, because this room includes people who will and should push back. This is a static structural resource. It does not model mutant-state ensembles, free-energy changes, metabolism, expression, copy number, or field-level evolution. Distance percentile is context, not causation. EPSPS is underpowered at one position. ACCase rests on a homology model, not a solved weed structure. And structure choice and core definition influence the output — which is exactly why everything is scripted, seeded, documented, and run both with and without the direct-core residues. The limits are stated so the claims stay inside them.</a:t>
+              <a:t>Being explicit about limits, because this room includes people who will and should push back. This is a static structural resource. It does not model mutant-state ensembles, free-energy changes, metabolism, expression, copy number, or field-level evolution. Distance percentile is context, not causation. EPSPS now has two accepted positions, not one, and is statistically significant, though still the smallest pooled family. ACCase rests on a homology model, not a solved weed structure. And structure choice and core definition influence the output — which is exactly why everything is scripted, seeded, documented, and run both with and without the direct-core residues. The limits are stated so the claims stay inside them.</a:t>
             </a:r>
             <a:endParaRPr lang="en-US" dirty="0"/>
           </a:p>
@@ -2549,7 +2549,7 @@
           <a:p>
             <a:r>
               <a:rPr lang="en-US" dirty="0"/>
-              <a:t>Stage one, and a choice we're proud of: evidence discipline. Every mutation row has to be backed by a primary source. We refused to infer accessions by sequence-length matching or guesswork — if a paper didn't give an accession, we kept the residue as literature-supported but never invented a database ID. We also refused to pool engineered or lab-selected mutations as if they were weed-evolved. This is boring and unglamorous and it's exactly what makes the downstream statistics trustworthy. Seventeen mutation rows survived this gate across four families.</a:t>
+              <a:t>Stage one, and a choice we're proud of: evidence discipline. Every mutation row has to be backed by a primary source. We refused to infer accessions by sequence-length matching or guesswork — if a paper didn't give an accession, we kept the residue as literature-supported but never invented a database ID. We also refused to pool engineered or lab-selected mutations as if they were weed-evolved. This is boring and unglamorous and it's exactly what makes the downstream statistics trustworthy. Nineteen mutation rows survived this gate across four families.</a:t>
             </a:r>
             <a:endParaRPr lang="en-US" dirty="0"/>
           </a:p>

</xml_diff>